<commit_message>
Add tax/policy explanation and sources for the 31-March spikes on the data slide
</commit_message>
<xml_diff>
--- a/slides/Slide_presentation.pptx
+++ b/slides/Slide_presentation.pptx
@@ -2074,6 +2074,10 @@
           </a:solidFill>
           <a:ln/>
         </p:spPr>
+        <p:txBody>
+          <a:bodyPr/>
+          <a:p/>
+        </p:txBody>
       </p:sp>
       <p:sp>
         <p:nvSpPr>
@@ -2677,6 +2681,10 @@
           </a:solidFill>
           <a:ln/>
         </p:spPr>
+        <p:txBody>
+          <a:bodyPr/>
+          <a:p/>
+        </p:txBody>
       </p:sp>
       <p:sp>
         <p:nvSpPr>
@@ -2779,6 +2787,10 @@
           </a:solidFill>
           <a:ln/>
         </p:spPr>
+        <p:txBody>
+          <a:bodyPr/>
+          <a:p/>
+        </p:txBody>
       </p:sp>
       <p:sp>
         <p:nvSpPr>
@@ -2881,6 +2893,10 @@
           </a:solidFill>
           <a:ln/>
         </p:spPr>
+        <p:txBody>
+          <a:bodyPr/>
+          <a:p/>
+        </p:txBody>
       </p:sp>
       <p:sp>
         <p:nvSpPr>
@@ -3082,6 +3098,10 @@
             </a:outerShdw>
           </a:effectLst>
         </p:spPr>
+        <p:txBody>
+          <a:bodyPr/>
+          <a:p/>
+        </p:txBody>
       </p:sp>
       <p:pic>
         <p:nvPicPr>
@@ -3114,18 +3134,18 @@
         </p:nvSpPr>
         <p:spPr>
           <a:xfrm>
-            <a:off x="8041332" y="8398371"/>
-            <a:ext cx="9592537" cy="1202829"/>
-          </a:xfrm>
-          <a:prstGeom prst="rect">
-            <a:avLst/>
-          </a:prstGeom>
-          <a:noFill/>
-          <a:ln/>
-        </p:spPr>
-        <p:txBody>
-          <a:bodyPr wrap="square" lIns="25400" tIns="25400" rIns="25400" bIns="25400" rtlCol="0" anchor="t">
-            <a:normAutofit/>
+            <a:off x="8041332" y="8229600"/>
+            <a:ext cx="9592537" cy="2011680"/>
+          </a:xfrm>
+          <a:prstGeom prst="rect">
+            <a:avLst/>
+          </a:prstGeom>
+          <a:noFill/>
+          <a:ln/>
+        </p:spPr>
+        <p:txBody>
+          <a:bodyPr wrap="square" lIns="25400" tIns="25400" rIns="25400" bIns="25400" rtlCol="0" anchor="t">
+            <a:noAutofit/>
           </a:bodyPr>
           <a:lstStyle/>
           <a:p>
@@ -3133,19 +3153,11 @@
               <a:lnSpc>
                 <a:spcPct val="145000"/>
               </a:lnSpc>
-              <a:buNone/>
-            </a:pPr>
-            <a:r>
-              <a:rPr lang="en-US" sz="2100" b="1" dirty="0">
-                <a:solidFill>
-                  <a:srgbClr val="B3541E"/>
-                </a:solidFill>
-                <a:latin typeface="Arial" pitchFamily="34" charset="0"/>
-                <a:ea typeface="Arial" pitchFamily="34" charset="-122"/>
-                <a:cs typeface="Arial" pitchFamily="34" charset="-120"/>
-              </a:rPr>
-              <a:t>The 31-March artifact: </a:t>
-            </a:r>
+              <a:spcAft>
+                <a:spcPts val="300"/>
+              </a:spcAft>
+              <a:buNone/>
+            </a:pPr>
             <a:pPr algn="l" indent="0" marL="0">
               <a:lnSpc>
                 <a:spcPct val="145000"/>
@@ -3153,17 +3165,106 @@
               <a:buNone/>
             </a:pPr>
             <a:r>
-              <a:rPr lang="en-US" sz="2100" dirty="0">
+              <a:rPr sz="1800" b="1">
+                <a:solidFill>
+                  <a:srgbClr val="B3541E"/>
+                </a:solidFill>
+                <a:latin typeface="Arial"/>
+              </a:rPr>
+              <a:t>Why the two 31-March spikes?</a:t>
+            </a:r>
+            <a:endParaRPr lang="en-US" sz="2100" dirty="0"/>
+          </a:p>
+          <a:p>
+            <a:pPr>
+              <a:spcAft>
+                <a:spcPts val="300"/>
+              </a:spcAft>
+            </a:pPr>
+            <a:r>
+              <a:rPr sz="1400" b="1">
+                <a:solidFill>
+                  <a:srgbClr val="B3541E"/>
+                </a:solidFill>
+                <a:latin typeface="Arial"/>
+              </a:rPr>
+              <a:t>2020 </a:t>
+            </a:r>
+            <a:r>
+              <a:rPr sz="1400" b="0">
                 <a:solidFill>
                   <a:srgbClr val="6B6355"/>
                 </a:solidFill>
-                <a:latin typeface="Arial" pitchFamily="34" charset="0"/>
-                <a:ea typeface="Arial" pitchFamily="34" charset="-122"/>
-                <a:cs typeface="Arial" pitchFamily="34" charset="-120"/>
-              </a:rPr>
-              <a:t>financial year-end dates are imputed onto thousands of records, creating false monthly spikes — treat as coarse dates, not real activity.</a:t>
-            </a:r>
-            <a:endParaRPr lang="en-US" sz="2100" dirty="0"/>
+                <a:latin typeface="Arial"/>
+              </a:rPr>
+              <a:t>— rush to beat the 6 Apr CGT overhaul (Private Residence &amp; Lettings Relief cut, 30-day reporting) + Section 24 &amp; MEES → landlords sell.</a:t>
+            </a:r>
+          </a:p>
+          <a:p>
+            <a:pPr>
+              <a:spcAft>
+                <a:spcPts val="300"/>
+              </a:spcAft>
+            </a:pPr>
+            <a:r>
+              <a:rPr sz="1400" b="1">
+                <a:solidFill>
+                  <a:srgbClr val="B3541E"/>
+                </a:solidFill>
+                <a:latin typeface="Arial"/>
+              </a:rPr>
+              <a:t>2019 </a:t>
+            </a:r>
+            <a:r>
+              <a:rPr sz="1400" b="0">
+                <a:solidFill>
+                  <a:srgbClr val="6B6355"/>
+                </a:solidFill>
+                <a:latin typeface="Arial"/>
+              </a:rPr>
+              <a:t>— SDLT filing cut to 14 days from 1 Mar (HMRC: pre/post figures ‘not comparable’); Brexit’s 29 Mar deadline froze activity.</a:t>
+            </a:r>
+          </a:p>
+          <a:p>
+            <a:pPr>
+              <a:spcAft>
+                <a:spcPts val="300"/>
+              </a:spcAft>
+            </a:pPr>
+            <a:r>
+              <a:rPr sz="1400" b="1">
+                <a:solidFill>
+                  <a:srgbClr val="B3541E"/>
+                </a:solidFill>
+                <a:latin typeface="Arial"/>
+              </a:rPr>
+              <a:t>Caveat </a:t>
+            </a:r>
+            <a:r>
+              <a:rPr sz="1400" b="0">
+                <a:solidFill>
+                  <a:srgbClr val="6B6355"/>
+                </a:solidFill>
+                <a:latin typeface="Arial"/>
+              </a:rPr>
+              <a:t>— records are duplicated &amp; imputed to the year-end, so we treat sale dates as coarse (financial year), not exact.</a:t>
+            </a:r>
+          </a:p>
+          <a:p>
+            <a:pPr>
+              <a:spcAft>
+                <a:spcPts val="0"/>
+              </a:spcAft>
+            </a:pPr>
+            <a:r>
+              <a:rPr sz="1050" b="0">
+                <a:solidFill>
+                  <a:srgbClr val="A89E8B"/>
+                </a:solidFill>
+                <a:latin typeface="Courier New"/>
+              </a:rPr>
+              <a:t>Sources: GOV.UK (CGT · monthly property transactions · MEES) · Crowe UK · LandlordZone</a:t>
+            </a:r>
           </a:p>
         </p:txBody>
       </p:sp>

</xml_diff>